<commit_message>
final version of documents
</commit_message>
<xml_diff>
--- a/docs/final_report/cs610_final_report_presentation.pptx
+++ b/docs/final_report/cs610_final_report_presentation.pptx
@@ -121,6 +121,15 @@
     </p:ext>
   </p:extLst>
 </p:presentation>
+</file>
+
+<file path=ppt/revisionInfo.xml><?xml version="1.0" encoding="utf-8"?>
+<p1510:revInfo xmlns:a="http://schemas.openxmlformats.org/drawingml/2006/main" xmlns:r="http://schemas.openxmlformats.org/officeDocument/2006/relationships" xmlns:p1510="http://schemas.microsoft.com/office/powerpoint/2015/10/main">
+  <p1510:revLst>
+    <p1510:client id="{338A3723-C774-96C3-F02A-AADCAE282D9D}" v="22" dt="2026-06-04T18:44:28.505"/>
+    <p1510:client id="{6DB86085-EDE5-1AAA-3215-0A2A46B554C7}" v="5" dt="2026-06-04T04:14:10.511"/>
+  </p1510:revLst>
+</p1510:revInfo>
 </file>
 
 <file path=ppt/notesMasters/notesMaster1.xml><?xml version="1.0" encoding="utf-8"?>
@@ -4306,12 +4315,9 @@
           <a:ln/>
         </p:spPr>
         <p:txBody>
-          <a:bodyPr wrap="square" rtlCol="0" anchor="ctr"/>
-          <a:lstStyle/>
-          <a:p>
-            <a:pPr marL="0" indent="0" algn="l">
-              <a:buNone/>
-            </a:pPr>
+          <a:bodyPr wrap="square" lIns="91440" tIns="45720" rIns="91440" bIns="45720" rtlCol="0" anchor="ctr"/>
+          <a:lstStyle/>
+          <a:p>
             <a:r>
               <a:rPr lang="en-US" sz="2600" b="1">
                 <a:solidFill>
@@ -5310,7 +5316,7 @@
         <p:spPr>
           <a:xfrm>
             <a:off x="6096000" y="1130300"/>
-            <a:ext cx="2755900" cy="2387600"/>
+            <a:ext cx="2766483" cy="3049058"/>
           </a:xfrm>
           <a:prstGeom prst="rect">
             <a:avLst/>
@@ -5366,7 +5372,7 @@
         <p:spPr>
           <a:xfrm>
             <a:off x="3175000" y="1130300"/>
-            <a:ext cx="2755900" cy="2387600"/>
+            <a:ext cx="2755900" cy="3054350"/>
           </a:xfrm>
           <a:prstGeom prst="rect">
             <a:avLst/>
@@ -5421,8 +5427,8 @@
         </p:nvSpPr>
         <p:spPr>
           <a:xfrm>
-            <a:off x="254000" y="1130300"/>
-            <a:ext cx="2755900" cy="2387600"/>
+            <a:off x="259291" y="1130300"/>
+            <a:ext cx="2745318" cy="3049058"/>
           </a:xfrm>
           <a:prstGeom prst="rect">
             <a:avLst/>
@@ -5727,8 +5733,8 @@
         </p:nvSpPr>
         <p:spPr>
           <a:xfrm>
-            <a:off x="381000" y="1600200"/>
-            <a:ext cx="2501900" cy="1841500"/>
+            <a:off x="375709" y="1594909"/>
+            <a:ext cx="2507191" cy="2397124"/>
           </a:xfrm>
           <a:prstGeom prst="rect">
             <a:avLst/>
@@ -5739,18 +5745,14 @@
           </a:ln>
         </p:spPr>
         <p:txBody>
-          <a:bodyPr vertOverflow="overflow" vert="horz" wrap="square" rtlCol="0" anchor="t" anchorCtr="0">
+          <a:bodyPr vertOverflow="overflow" vert="horz" wrap="square" lIns="91440" tIns="45720" rIns="91440" bIns="45720" rtlCol="0" anchor="t" anchorCtr="0">
             <a:noAutofit/>
           </a:bodyPr>
           <a:lstStyle/>
           <a:p>
-            <a:pPr algn="l">
-              <a:lnSpc>
-                <a:spcPts val="1900"/>
-              </a:lnSpc>
-            </a:pPr>
-            <a:r>
-              <a:rPr lang="en-US" sz="1500">
+            <a:pPr algn="l"/>
+            <a:r>
+              <a:rPr lang="en-US">
                 <a:solidFill>
                   <a:srgbClr val="404040"/>
                 </a:solidFill>
@@ -5759,6 +5761,14 @@
               </a:rPr>
               <a:t>Constantinou, Fenton &amp; Neil (2012–13): BN for soccer forecasting — game variables only, no market movement.</a:t>
             </a:r>
+            <a:endParaRPr lang="en-US">
+              <a:solidFill>
+                <a:srgbClr val="404040"/>
+              </a:solidFill>
+              <a:latin typeface="Calibri"/>
+              <a:ea typeface="Calibri"/>
+              <a:cs typeface="Calibri"/>
+            </a:endParaRPr>
           </a:p>
         </p:txBody>
       </p:sp>
@@ -5922,18 +5932,14 @@
           </a:ln>
         </p:spPr>
         <p:txBody>
-          <a:bodyPr vertOverflow="overflow" vert="horz" wrap="square" rtlCol="0" anchor="t" anchorCtr="0">
+          <a:bodyPr vertOverflow="overflow" vert="horz" wrap="square" lIns="91440" tIns="45720" rIns="91440" bIns="45720" rtlCol="0" anchor="t" anchorCtr="0">
             <a:noAutofit/>
           </a:bodyPr>
           <a:lstStyle/>
           <a:p>
-            <a:pPr algn="l">
-              <a:lnSpc>
-                <a:spcPts val="1900"/>
-              </a:lnSpc>
-            </a:pPr>
-            <a:r>
-              <a:rPr lang="en-US" sz="1500">
+            <a:pPr algn="l"/>
+            <a:r>
+              <a:rPr lang="en-US">
                 <a:solidFill>
                   <a:srgbClr val="404040"/>
                 </a:solidFill>
@@ -5942,6 +5948,14 @@
               </a:rPr>
               <a:t>Egidi, Pauli &amp; Torelli (2018): hierarchical Bayes blending odds — no conditional dependence structure.</a:t>
             </a:r>
+            <a:endParaRPr lang="en-US">
+              <a:solidFill>
+                <a:srgbClr val="404040"/>
+              </a:solidFill>
+              <a:latin typeface="Calibri"/>
+              <a:ea typeface="Calibri"/>
+              <a:cs typeface="Calibri"/>
+            </a:endParaRPr>
           </a:p>
         </p:txBody>
       </p:sp>
@@ -6105,18 +6119,14 @@
           </a:ln>
         </p:spPr>
         <p:txBody>
-          <a:bodyPr vertOverflow="overflow" vert="horz" wrap="square" rtlCol="0" anchor="t" anchorCtr="0">
+          <a:bodyPr vertOverflow="overflow" vert="horz" wrap="square" lIns="91440" tIns="45720" rIns="91440" bIns="45720" rtlCol="0" anchor="t" anchorCtr="0">
             <a:noAutofit/>
           </a:bodyPr>
           <a:lstStyle/>
           <a:p>
-            <a:pPr algn="l">
-              <a:lnSpc>
-                <a:spcPts val="1900"/>
-              </a:lnSpc>
-            </a:pPr>
-            <a:r>
-              <a:rPr lang="en-US" sz="1500">
+            <a:pPr algn="l"/>
+            <a:r>
+              <a:rPr lang="en-US">
                 <a:solidFill>
                   <a:srgbClr val="404040"/>
                 </a:solidFill>
@@ -6125,6 +6135,14 @@
               </a:rPr>
               <a:t>Simon (2024), Moskowitz (2021): line-movement efficiency — no game-stats integration.</a:t>
             </a:r>
+            <a:endParaRPr lang="en-US">
+              <a:solidFill>
+                <a:srgbClr val="404040"/>
+              </a:solidFill>
+              <a:latin typeface="Calibri"/>
+              <a:ea typeface="Calibri"/>
+              <a:cs typeface="Calibri"/>
+            </a:endParaRPr>
           </a:p>
         </p:txBody>
       </p:sp>
@@ -6142,8 +6160,8 @@
         </p:nvSpPr>
         <p:spPr>
           <a:xfrm>
-            <a:off x="254000" y="3759200"/>
-            <a:ext cx="8636000" cy="1117600"/>
+            <a:off x="269875" y="4293658"/>
+            <a:ext cx="8598959" cy="593725"/>
           </a:xfrm>
           <a:prstGeom prst="rect">
             <a:avLst/>
@@ -6198,8 +6216,8 @@
         </p:nvSpPr>
         <p:spPr>
           <a:xfrm>
-            <a:off x="254000" y="3759200"/>
-            <a:ext cx="50800" cy="1117600"/>
+            <a:off x="264583" y="4288366"/>
+            <a:ext cx="24342" cy="593725"/>
           </a:xfrm>
           <a:prstGeom prst="rect">
             <a:avLst/>
@@ -6252,7 +6270,7 @@
         </p:nvSpPr>
         <p:spPr>
           <a:xfrm>
-            <a:off x="457200" y="3860800"/>
+            <a:off x="457200" y="4421717"/>
             <a:ext cx="2540000" cy="304800"/>
           </a:xfrm>
           <a:prstGeom prst="rect">
@@ -6279,50 +6297,6 @@
                 <a:cs typeface="Calibri"/>
               </a:rPr>
               <a:t>GAP CONFIRMED</a:t>
-            </a:r>
-          </a:p>
-        </p:txBody>
-      </p:sp>
-      <p:sp>
-        <p:nvSpPr>
-          <p:cNvPr id="42" name="TextBox 41">
-            <a:extLst>
-              <a:ext uri="{FF2B5EF4-FFF2-40B4-BE49-F238E27FC236}">
-                <a16:creationId xmlns:a16="http://schemas.microsoft.com/office/drawing/2014/main" id="{5BF94E69-CA15-01B8-A118-ADC80E63E5C6}"/>
-              </a:ext>
-            </a:extLst>
-          </p:cNvPr>
-          <p:cNvSpPr txBox="1"/>
-          <p:nvPr/>
-        </p:nvSpPr>
-        <p:spPr>
-          <a:xfrm>
-            <a:off x="457200" y="4191000"/>
-            <a:ext cx="8305800" cy="304800"/>
-          </a:xfrm>
-          <a:prstGeom prst="rect">
-            <a:avLst/>
-          </a:prstGeom>
-          <a:noFill/>
-          <a:ln>
-            <a:noFill/>
-          </a:ln>
-        </p:spPr>
-        <p:txBody>
-          <a:bodyPr vertOverflow="overflow" vert="horz" wrap="none" rtlCol="0" anchor="t" anchorCtr="0">
-            <a:noAutofit/>
-          </a:bodyPr>
-          <a:lstStyle/>
-          <a:p>
-            <a:r>
-              <a:rPr lang="en-US" sz="1500">
-                <a:solidFill>
-                  <a:srgbClr val="404040"/>
-                </a:solidFill>
-                <a:latin typeface="Calibri"/>
-                <a:cs typeface="Calibri"/>
-              </a:rPr>
-              <a:t>Walsh &amp; Joshi (2024) systematic review of 219 papers confirms no study integrates all three silos.</a:t>
             </a:r>
           </a:p>
         </p:txBody>

</xml_diff>